<commit_message>
Add architecture diagram to deck
</commit_message>
<xml_diff>
--- a/docs/decks/maintenance-wizard-ai-capabilities-hackathon-objectives.pptx
+++ b/docs/decks/maintenance-wizard-ai-capabilities-hackathon-objectives.pptx
@@ -2,24 +2,25 @@
 <file path=ppt/presentation.xml><?xml version="1.0" encoding="utf-8"?>
 <p:presentation xmlns:p="http://schemas.openxmlformats.org/presentationml/2006/main">
   <p:sldMasterIdLst>
-    <p:sldMasterId xmlns:r="http://schemas.openxmlformats.org/officeDocument/2006/relationships" id="2147483648" r:id="Rc3e80dd1287b4c20"/>
+    <p:sldMasterId xmlns:r="http://schemas.openxmlformats.org/officeDocument/2006/relationships" id="2147483648" r:id="R536921ac05de48cb"/>
   </p:sldMasterIdLst>
   <p:notesMasterIdLst>
-    <p:notesMasterId xmlns:r="http://schemas.openxmlformats.org/officeDocument/2006/relationships" r:id="Rbefb43b5e5f44993"/>
+    <p:notesMasterId xmlns:r="http://schemas.openxmlformats.org/officeDocument/2006/relationships" r:id="R835ceb4fcd7d45f1"/>
   </p:notesMasterIdLst>
   <p:sldIdLst>
-    <p:sldId xmlns:r="http://schemas.openxmlformats.org/officeDocument/2006/relationships" id="256" r:id="Rf5fa336649dd4808"/>
-    <p:sldId xmlns:r="http://schemas.openxmlformats.org/officeDocument/2006/relationships" id="257" r:id="Rf6681538b32441ab"/>
-    <p:sldId xmlns:r="http://schemas.openxmlformats.org/officeDocument/2006/relationships" id="258" r:id="R68b8f99b1f9b4562"/>
-    <p:sldId xmlns:r="http://schemas.openxmlformats.org/officeDocument/2006/relationships" id="259" r:id="R80442a2a69874b32"/>
-    <p:sldId xmlns:r="http://schemas.openxmlformats.org/officeDocument/2006/relationships" id="260" r:id="R1faba47d8ac14621"/>
-    <p:sldId xmlns:r="http://schemas.openxmlformats.org/officeDocument/2006/relationships" id="261" r:id="R9168a3c3ef0d4057"/>
-    <p:sldId xmlns:r="http://schemas.openxmlformats.org/officeDocument/2006/relationships" id="262" r:id="Rd55c55c2a75c43ba"/>
-    <p:sldId xmlns:r="http://schemas.openxmlformats.org/officeDocument/2006/relationships" id="263" r:id="R40aea8ff1d5b4b1d"/>
-    <p:sldId xmlns:r="http://schemas.openxmlformats.org/officeDocument/2006/relationships" id="264" r:id="R3cafe8746ac348a0"/>
-    <p:sldId xmlns:r="http://schemas.openxmlformats.org/officeDocument/2006/relationships" id="265" r:id="R075aa7493bd249d1"/>
-    <p:sldId xmlns:r="http://schemas.openxmlformats.org/officeDocument/2006/relationships" id="266" r:id="Rea301947b7a54e9a"/>
-    <p:sldId xmlns:r="http://schemas.openxmlformats.org/officeDocument/2006/relationships" id="267" r:id="R950dc48bf1224057"/>
+    <p:sldId xmlns:r="http://schemas.openxmlformats.org/officeDocument/2006/relationships" id="256" r:id="R7a4671d66fed4f14"/>
+    <p:sldId xmlns:r="http://schemas.openxmlformats.org/officeDocument/2006/relationships" id="257" r:id="R769ffc4514664800"/>
+    <p:sldId xmlns:r="http://schemas.openxmlformats.org/officeDocument/2006/relationships" id="258" r:id="Rf1770f797e414c83"/>
+    <p:sldId xmlns:r="http://schemas.openxmlformats.org/officeDocument/2006/relationships" id="259" r:id="R1c8e9d975e544f6e"/>
+    <p:sldId xmlns:r="http://schemas.openxmlformats.org/officeDocument/2006/relationships" id="260" r:id="R3dbd7db5a21841df"/>
+    <p:sldId xmlns:r="http://schemas.openxmlformats.org/officeDocument/2006/relationships" id="261" r:id="R65315dfd64d3479c"/>
+    <p:sldId xmlns:r="http://schemas.openxmlformats.org/officeDocument/2006/relationships" id="262" r:id="R2325d287ff904877"/>
+    <p:sldId xmlns:r="http://schemas.openxmlformats.org/officeDocument/2006/relationships" id="263" r:id="R3d03ddb83ee44749"/>
+    <p:sldId xmlns:r="http://schemas.openxmlformats.org/officeDocument/2006/relationships" id="264" r:id="R84123f2b4e5d438a"/>
+    <p:sldId xmlns:r="http://schemas.openxmlformats.org/officeDocument/2006/relationships" id="265" r:id="Rfef044d7119d4a47"/>
+    <p:sldId xmlns:r="http://schemas.openxmlformats.org/officeDocument/2006/relationships" id="266" r:id="Ra53f5be9797140c1"/>
+    <p:sldId xmlns:r="http://schemas.openxmlformats.org/officeDocument/2006/relationships" id="267" r:id="R9b86ed917c8f4458"/>
+    <p:sldId xmlns:r="http://schemas.openxmlformats.org/officeDocument/2006/relationships" id="268" r:id="R41d55a32c17d4c17"/>
   </p:sldIdLst>
   <p:sldSz cx="12192000" cy="6858000"/>
   <p:notesSz cx="6858000" cy="9144000"/>
@@ -726,6 +727,72 @@
 </p:notes>
 </file>
 
+<file path=ppt/notesSlides/notesSlide13.xml><?xml version="1.0" encoding="utf-8"?>
+<p:notes xmlns:p="http://schemas.openxmlformats.org/presentationml/2006/main">
+  <p:cSld>
+    <p:spTree>
+      <p:nvGrpSpPr>
+        <p:cNvPr id="1" name=""/>
+        <p:cNvGrpSpPr/>
+        <p:nvPr/>
+      </p:nvGrpSpPr>
+      <p:grpSpPr>
+        <a:xfrm xmlns:a="http://schemas.openxmlformats.org/drawingml/2006/main"/>
+      </p:grpSpPr>
+      <p:sp>
+        <p:nvSpPr>
+          <p:cNvPr id="2" name="Slide Image Placeholder 1"/>
+          <p:cNvSpPr>
+            <a:spLocks xmlns:a="http://schemas.openxmlformats.org/drawingml/2006/main" noGrp="1"/>
+          </p:cNvSpPr>
+          <p:nvPr>
+            <p:ph type="sldImg" idx="0"/>
+          </p:nvPr>
+        </p:nvSpPr>
+        <p:spPr/>
+      </p:sp>
+      <p:sp>
+        <p:nvSpPr>
+          <p:cNvPr id="3" name="Notes Placeholder 2"/>
+          <p:cNvSpPr>
+            <a:spLocks xmlns:a="http://schemas.openxmlformats.org/drawingml/2006/main" noGrp="1"/>
+          </p:cNvSpPr>
+          <p:nvPr>
+            <p:ph type="body" idx="1"/>
+          </p:nvPr>
+        </p:nvSpPr>
+        <p:spPr/>
+        <p:txBody>
+          <a:bodyPr xmlns:a="http://schemas.openxmlformats.org/drawingml/2006/main"/>
+          <a:lstStyle xmlns:a="http://schemas.openxmlformats.org/drawingml/2006/main"/>
+          <a:p xmlns:a="http://schemas.openxmlformats.org/drawingml/2006/main"/>
+        </p:txBody>
+      </p:sp>
+      <p:sp>
+        <p:nvSpPr>
+          <p:cNvPr id="4" name="Slide Number Placeholder 3"/>
+          <p:cNvSpPr>
+            <a:spLocks xmlns:a="http://schemas.openxmlformats.org/drawingml/2006/main" noGrp="1"/>
+          </p:cNvSpPr>
+          <p:nvPr>
+            <p:ph type="sldNum" idx="5"/>
+          </p:nvPr>
+        </p:nvSpPr>
+        <p:spPr/>
+        <p:txBody>
+          <a:bodyPr xmlns:a="http://schemas.openxmlformats.org/drawingml/2006/main"/>
+          <a:lstStyle xmlns:a="http://schemas.openxmlformats.org/drawingml/2006/main"/>
+          <a:p xmlns:a="http://schemas.openxmlformats.org/drawingml/2006/main"/>
+        </p:txBody>
+      </p:sp>
+    </p:spTree>
+  </p:cSld>
+  <p:clrMapOvr>
+    <a:masterClrMapping xmlns:a="http://schemas.openxmlformats.org/drawingml/2006/main"/>
+  </p:clrMapOvr>
+</p:notes>
+</file>
+
 <file path=ppt/notesSlides/notesSlide2.xml><?xml version="1.0" encoding="utf-8"?>
 <p:notes xmlns:p="http://schemas.openxmlformats.org/presentationml/2006/main">
   <p:cSld>
@@ -1292,7 +1359,7 @@
   </p:cSld>
   <p:clrMap bg1="lt1" tx1="dk1" bg2="lt2" tx2="dk2" accent1="accent1" accent2="accent2" accent3="accent3" accent4="accent4" accent5="accent5" accent6="accent6" hlink="hlink" folHlink="folHlink"/>
   <p:sldLayoutIdLst>
-    <p:sldLayoutId xmlns:r="http://schemas.openxmlformats.org/officeDocument/2006/relationships" id="2147483649" r:id="Rff9a1747da1e44e3"/>
+    <p:sldLayoutId xmlns:r="http://schemas.openxmlformats.org/officeDocument/2006/relationships" id="2147483649" r:id="R6d75ea268f8a4e4d"/>
   </p:sldLayoutIdLst>
   <p:txStyles>
     <p:titleStyle>
@@ -10577,6 +10644,7 @@
           <a:lstStyle xmlns:a="http://schemas.openxmlformats.org/drawingml/2006/main"/>
           <a:p xmlns:a="http://schemas.openxmlformats.org/drawingml/2006/main">
             <a:pPr algn="l">
+              <a:buNone/>
               <a:defRPr sz="975" b="1">
                 <a:solidFill>
                   <a:srgbClr val="E8E1D4"/>
@@ -10641,6 +10709,7 @@
           <a:lstStyle xmlns:a="http://schemas.openxmlformats.org/drawingml/2006/main"/>
           <a:p xmlns:a="http://schemas.openxmlformats.org/drawingml/2006/main">
             <a:pPr algn="l">
+              <a:buNone/>
               <a:defRPr sz="2775" b="1">
                 <a:solidFill>
                   <a:srgbClr val="FFFFFF"/>
@@ -10705,6 +10774,7 @@
           <a:lstStyle xmlns:a="http://schemas.openxmlformats.org/drawingml/2006/main"/>
           <a:p xmlns:a="http://schemas.openxmlformats.org/drawingml/2006/main">
             <a:pPr algn="l">
+              <a:buNone/>
               <a:defRPr sz="1200" b="0">
                 <a:solidFill>
                   <a:srgbClr val="C8D2CC"/>
@@ -10769,6 +10839,7 @@
           <a:lstStyle xmlns:a="http://schemas.openxmlformats.org/drawingml/2006/main"/>
           <a:p xmlns:a="http://schemas.openxmlformats.org/drawingml/2006/main">
             <a:pPr algn="l">
+              <a:buNone/>
               <a:defRPr sz="825" b="1">
                 <a:solidFill>
                   <a:srgbClr val="F6B54A"/>
@@ -10833,6 +10904,7 @@
           <a:lstStyle xmlns:a="http://schemas.openxmlformats.org/drawingml/2006/main"/>
           <a:p xmlns:a="http://schemas.openxmlformats.org/drawingml/2006/main">
             <a:pPr algn="l">
+              <a:buNone/>
               <a:defRPr sz="825" b="1">
                 <a:solidFill>
                   <a:srgbClr val="F6B54A"/>
@@ -10897,6 +10969,7 @@
           <a:lstStyle xmlns:a="http://schemas.openxmlformats.org/drawingml/2006/main"/>
           <a:p xmlns:a="http://schemas.openxmlformats.org/drawingml/2006/main">
             <a:pPr algn="l">
+              <a:buNone/>
               <a:defRPr sz="825" b="1">
                 <a:solidFill>
                   <a:srgbClr val="F6B54A"/>
@@ -11031,6 +11104,7 @@
           <a:lstStyle xmlns:a="http://schemas.openxmlformats.org/drawingml/2006/main"/>
           <a:p xmlns:a="http://schemas.openxmlformats.org/drawingml/2006/main">
             <a:pPr algn="l">
+              <a:buNone/>
               <a:defRPr sz="900" b="1">
                 <a:solidFill>
                   <a:srgbClr val="FFFFFF"/>
@@ -11095,6 +11169,7 @@
           <a:lstStyle xmlns:a="http://schemas.openxmlformats.org/drawingml/2006/main"/>
           <a:p xmlns:a="http://schemas.openxmlformats.org/drawingml/2006/main">
             <a:pPr algn="l">
+              <a:buNone/>
               <a:defRPr sz="863" b="0">
                 <a:solidFill>
                   <a:srgbClr val="C8D2CC"/>
@@ -11159,6 +11234,7 @@
           <a:lstStyle xmlns:a="http://schemas.openxmlformats.org/drawingml/2006/main"/>
           <a:p xmlns:a="http://schemas.openxmlformats.org/drawingml/2006/main">
             <a:pPr algn="l">
+              <a:buNone/>
               <a:defRPr sz="863" b="0">
                 <a:solidFill>
                   <a:srgbClr val="D9E2DD"/>
@@ -11293,6 +11369,7 @@
           <a:lstStyle xmlns:a="http://schemas.openxmlformats.org/drawingml/2006/main"/>
           <a:p xmlns:a="http://schemas.openxmlformats.org/drawingml/2006/main">
             <a:pPr algn="l">
+              <a:buNone/>
               <a:defRPr sz="900" b="1">
                 <a:solidFill>
                   <a:srgbClr val="FFFFFF"/>
@@ -11357,6 +11434,7 @@
           <a:lstStyle xmlns:a="http://schemas.openxmlformats.org/drawingml/2006/main"/>
           <a:p xmlns:a="http://schemas.openxmlformats.org/drawingml/2006/main">
             <a:pPr algn="l">
+              <a:buNone/>
               <a:defRPr sz="863" b="0">
                 <a:solidFill>
                   <a:srgbClr val="C8D2CC"/>
@@ -11421,6 +11499,7 @@
           <a:lstStyle xmlns:a="http://schemas.openxmlformats.org/drawingml/2006/main"/>
           <a:p xmlns:a="http://schemas.openxmlformats.org/drawingml/2006/main">
             <a:pPr algn="l">
+              <a:buNone/>
               <a:defRPr sz="863" b="0">
                 <a:solidFill>
                   <a:srgbClr val="D9E2DD"/>
@@ -11555,6 +11634,7 @@
           <a:lstStyle xmlns:a="http://schemas.openxmlformats.org/drawingml/2006/main"/>
           <a:p xmlns:a="http://schemas.openxmlformats.org/drawingml/2006/main">
             <a:pPr algn="l">
+              <a:buNone/>
               <a:defRPr sz="900" b="1">
                 <a:solidFill>
                   <a:srgbClr val="FFFFFF"/>
@@ -11619,6 +11699,7 @@
           <a:lstStyle xmlns:a="http://schemas.openxmlformats.org/drawingml/2006/main"/>
           <a:p xmlns:a="http://schemas.openxmlformats.org/drawingml/2006/main">
             <a:pPr algn="l">
+              <a:buNone/>
               <a:defRPr sz="863" b="0">
                 <a:solidFill>
                   <a:srgbClr val="C8D2CC"/>
@@ -11683,6 +11764,7 @@
           <a:lstStyle xmlns:a="http://schemas.openxmlformats.org/drawingml/2006/main"/>
           <a:p xmlns:a="http://schemas.openxmlformats.org/drawingml/2006/main">
             <a:pPr algn="l">
+              <a:buNone/>
               <a:defRPr sz="863" b="0">
                 <a:solidFill>
                   <a:srgbClr val="D9E2DD"/>
@@ -11817,6 +11899,7 @@
           <a:lstStyle xmlns:a="http://schemas.openxmlformats.org/drawingml/2006/main"/>
           <a:p xmlns:a="http://schemas.openxmlformats.org/drawingml/2006/main">
             <a:pPr algn="l">
+              <a:buNone/>
               <a:defRPr sz="900" b="1">
                 <a:solidFill>
                   <a:srgbClr val="FFFFFF"/>
@@ -11881,6 +11964,7 @@
           <a:lstStyle xmlns:a="http://schemas.openxmlformats.org/drawingml/2006/main"/>
           <a:p xmlns:a="http://schemas.openxmlformats.org/drawingml/2006/main">
             <a:pPr algn="l">
+              <a:buNone/>
               <a:defRPr sz="863" b="0">
                 <a:solidFill>
                   <a:srgbClr val="C8D2CC"/>
@@ -11945,6 +12029,7 @@
           <a:lstStyle xmlns:a="http://schemas.openxmlformats.org/drawingml/2006/main"/>
           <a:p xmlns:a="http://schemas.openxmlformats.org/drawingml/2006/main">
             <a:pPr algn="l">
+              <a:buNone/>
               <a:defRPr sz="863" b="0">
                 <a:solidFill>
                   <a:srgbClr val="D9E2DD"/>
@@ -12079,6 +12164,7 @@
           <a:lstStyle xmlns:a="http://schemas.openxmlformats.org/drawingml/2006/main"/>
           <a:p xmlns:a="http://schemas.openxmlformats.org/drawingml/2006/main">
             <a:pPr algn="l">
+              <a:buNone/>
               <a:defRPr sz="900" b="1">
                 <a:solidFill>
                   <a:srgbClr val="FFFFFF"/>
@@ -12143,6 +12229,7 @@
           <a:lstStyle xmlns:a="http://schemas.openxmlformats.org/drawingml/2006/main"/>
           <a:p xmlns:a="http://schemas.openxmlformats.org/drawingml/2006/main">
             <a:pPr algn="l">
+              <a:buNone/>
               <a:defRPr sz="863" b="0">
                 <a:solidFill>
                   <a:srgbClr val="C8D2CC"/>
@@ -12207,6 +12294,7 @@
           <a:lstStyle xmlns:a="http://schemas.openxmlformats.org/drawingml/2006/main"/>
           <a:p xmlns:a="http://schemas.openxmlformats.org/drawingml/2006/main">
             <a:pPr algn="l">
+              <a:buNone/>
               <a:defRPr sz="863" b="0">
                 <a:solidFill>
                   <a:srgbClr val="D9E2DD"/>
@@ -12341,6 +12429,7 @@
           <a:lstStyle xmlns:a="http://schemas.openxmlformats.org/drawingml/2006/main"/>
           <a:p xmlns:a="http://schemas.openxmlformats.org/drawingml/2006/main">
             <a:pPr algn="l">
+              <a:buNone/>
               <a:defRPr sz="900" b="1">
                 <a:solidFill>
                   <a:srgbClr val="FFFFFF"/>
@@ -12405,6 +12494,7 @@
           <a:lstStyle xmlns:a="http://schemas.openxmlformats.org/drawingml/2006/main"/>
           <a:p xmlns:a="http://schemas.openxmlformats.org/drawingml/2006/main">
             <a:pPr algn="l">
+              <a:buNone/>
               <a:defRPr sz="863" b="0">
                 <a:solidFill>
                   <a:srgbClr val="C8D2CC"/>
@@ -12469,6 +12559,7 @@
           <a:lstStyle xmlns:a="http://schemas.openxmlformats.org/drawingml/2006/main"/>
           <a:p xmlns:a="http://schemas.openxmlformats.org/drawingml/2006/main">
             <a:pPr algn="l">
+              <a:buNone/>
               <a:defRPr sz="863" b="0">
                 <a:solidFill>
                   <a:srgbClr val="D9E2DD"/>
@@ -12568,6 +12659,7 @@
           <a:lstStyle xmlns:a="http://schemas.openxmlformats.org/drawingml/2006/main"/>
           <a:p xmlns:a="http://schemas.openxmlformats.org/drawingml/2006/main">
             <a:pPr algn="ctr">
+              <a:buNone/>
               <a:defRPr sz="900" b="0">
                 <a:solidFill>
                   <a:srgbClr val="E8E1D4"/>
@@ -12667,6 +12759,7 @@
           <a:lstStyle xmlns:a="http://schemas.openxmlformats.org/drawingml/2006/main"/>
           <a:p xmlns:a="http://schemas.openxmlformats.org/drawingml/2006/main">
             <a:pPr algn="l">
+              <a:buNone/>
               <a:defRPr sz="750" b="0">
                 <a:solidFill>
                   <a:srgbClr val="91A29C"/>
@@ -12731,6 +12824,7 @@
           <a:lstStyle xmlns:a="http://schemas.openxmlformats.org/drawingml/2006/main"/>
           <a:p xmlns:a="http://schemas.openxmlformats.org/drawingml/2006/main">
             <a:pPr algn="r">
+              <a:buNone/>
               <a:defRPr sz="1125" b="1">
                 <a:solidFill>
                   <a:srgbClr val="E8E1D4"/>
@@ -12758,6 +12852,423 @@
     <p:extLst>
       <p:ext uri="{BB962C8B-B14F-4D97-AF65-F5344CB8AC3E}">
         <p14:creationId xmlns:p14="http://schemas.microsoft.com/office/powerpoint/2010/main" val="427057131"/>
+      </p:ext>
+    </p:extLst>
+  </p:cSld>
+</p:sld>
+</file>
+
+<file path=ppt/slides/slide13.xml><?xml version="1.0" encoding="utf-8"?>
+<p:sld xmlns:p="http://schemas.openxmlformats.org/presentationml/2006/main">
+  <p:cSld>
+    <p:bg>
+      <p:bgPr>
+        <a:solidFill xmlns:a="http://schemas.openxmlformats.org/drawingml/2006/main">
+          <a:srgbClr val="F6FBFF"/>
+        </a:solidFill>
+      </p:bgPr>
+    </p:bg>
+    <p:spTree>
+      <p:nvGrpSpPr>
+        <p:cNvPr id="1" name=""/>
+        <p:cNvGrpSpPr/>
+        <p:nvPr/>
+      </p:nvGrpSpPr>
+      <p:grpSpPr>
+        <a:xfrm xmlns:a="http://schemas.openxmlformats.org/drawingml/2006/main"/>
+      </p:grpSpPr>
+      <p:sp>
+        <p:nvSpPr>
+          <p:cNvPr id="1" name="architecture-slide-background-grid">
+            <a:extLst xmlns:a="http://schemas.openxmlformats.org/drawingml/2006/main">
+              <a:ext uri="{FF2B5EF4-FFF2-40B4-BE49-F238E27FC236}">
+                <a16:creationId xmlns:a16="http://schemas.microsoft.com/office/drawing/2014/main" id="{99188D25-1D54-49AC-8D7F-D2B2CB0104F1}"/>
+              </a:ext>
+            </a:extLst>
+          </p:cNvPr>
+          <p:cNvSpPr>
+            <a:spLocks xmlns:a="http://schemas.openxmlformats.org/drawingml/2006/main" noGrp="1"/>
+          </p:cNvSpPr>
+          <p:nvPr/>
+        </p:nvSpPr>
+        <p:spPr>
+          <a:xfrm xmlns:a="http://schemas.openxmlformats.org/drawingml/2006/main">
+            <a:off x="0" y="0"/>
+            <a:ext cx="12192000" cy="6858000"/>
+          </a:xfrm>
+          <a:prstGeom xmlns:a="http://schemas.openxmlformats.org/drawingml/2006/main" prst="rect">
+            <a:avLst/>
+          </a:prstGeom>
+          <a:solidFill xmlns:a="http://schemas.openxmlformats.org/drawingml/2006/main">
+            <a:srgbClr val="F6FBFF"/>
+          </a:solidFill>
+          <a:ln xmlns:a="http://schemas.openxmlformats.org/drawingml/2006/main" w="0">
+            <a:noFill/>
+            <a:prstDash val="solid"/>
+          </a:ln>
+        </p:spPr>
+      </p:sp>
+      <p:sp>
+        <p:nvSpPr>
+          <p:cNvPr id="2" name="architecture-slide-shell">
+            <a:extLst xmlns:a="http://schemas.openxmlformats.org/drawingml/2006/main">
+              <a:ext uri="{FF2B5EF4-FFF2-40B4-BE49-F238E27FC236}">
+                <a16:creationId xmlns:a16="http://schemas.microsoft.com/office/drawing/2014/main" id="{6AB5FE48-DE31-4F64-8F03-E70B264115D1}"/>
+              </a:ext>
+            </a:extLst>
+          </p:cNvPr>
+          <p:cNvSpPr>
+            <a:spLocks xmlns:a="http://schemas.openxmlformats.org/drawingml/2006/main" noGrp="1"/>
+          </p:cNvSpPr>
+          <p:nvPr/>
+        </p:nvSpPr>
+        <p:spPr>
+          <a:xfrm xmlns:a="http://schemas.openxmlformats.org/drawingml/2006/main">
+            <a:off x="400050" y="304800"/>
+            <a:ext cx="11391900" cy="6248400"/>
+          </a:xfrm>
+          <a:prstGeom xmlns:a="http://schemas.openxmlformats.org/drawingml/2006/main" prst="roundRect">
+            <a:avLst>
+              <a:gd name="adj" fmla="val 2439"/>
+            </a:avLst>
+          </a:prstGeom>
+          <a:solidFill xmlns:a="http://schemas.openxmlformats.org/drawingml/2006/main">
+            <a:srgbClr val="FFFFFF"/>
+          </a:solidFill>
+          <a:ln xmlns:a="http://schemas.openxmlformats.org/drawingml/2006/main" w="10478">
+            <a:solidFill>
+              <a:srgbClr val="D7E5EF"/>
+            </a:solidFill>
+            <a:prstDash val="solid"/>
+          </a:ln>
+        </p:spPr>
+        <p:style>
+          <a:lnRef xmlns:a="http://schemas.openxmlformats.org/drawingml/2006/main" idx="0"/>
+          <a:fillRef xmlns:a="http://schemas.openxmlformats.org/drawingml/2006/main" idx="0"/>
+          <a:effectRef xmlns:a="http://schemas.openxmlformats.org/drawingml/2006/main" idx="6"/>
+          <a:fontRef xmlns:a="http://schemas.openxmlformats.org/drawingml/2006/main" idx="major"/>
+        </p:style>
+      </p:sp>
+      <p:sp>
+        <p:nvSpPr>
+          <p:cNvPr id="3" name="architecture-slide-eyebrow">
+            <a:extLst xmlns:a="http://schemas.openxmlformats.org/drawingml/2006/main">
+              <a:ext uri="{FF2B5EF4-FFF2-40B4-BE49-F238E27FC236}">
+                <a16:creationId xmlns:a16="http://schemas.microsoft.com/office/drawing/2014/main" id="{7EDFF309-30D1-4F86-959F-7D2963ACD152}"/>
+              </a:ext>
+            </a:extLst>
+          </p:cNvPr>
+          <p:cNvSpPr>
+            <a:spLocks xmlns:a="http://schemas.openxmlformats.org/drawingml/2006/main" noGrp="1"/>
+          </p:cNvSpPr>
+          <p:nvPr/>
+        </p:nvSpPr>
+        <p:spPr>
+          <a:xfrm xmlns:a="http://schemas.openxmlformats.org/drawingml/2006/main">
+            <a:off x="723900" y="514350"/>
+            <a:ext cx="2762250" cy="228600"/>
+          </a:xfrm>
+          <a:prstGeom xmlns:a="http://schemas.openxmlformats.org/drawingml/2006/main" prst="rect">
+            <a:avLst/>
+          </a:prstGeom>
+          <a:noFill xmlns:a="http://schemas.openxmlformats.org/drawingml/2006/main"/>
+          <a:ln xmlns:a="http://schemas.openxmlformats.org/drawingml/2006/main" w="0">
+            <a:noFill/>
+            <a:prstDash val="solid"/>
+          </a:ln>
+        </p:spPr>
+        <p:txBody>
+          <a:bodyPr xmlns:a="http://schemas.openxmlformats.org/drawingml/2006/main"/>
+          <a:lstStyle xmlns:a="http://schemas.openxmlformats.org/drawingml/2006/main"/>
+          <a:p xmlns:a="http://schemas.openxmlformats.org/drawingml/2006/main">
+            <a:pPr>
+              <a:defRPr sz="900" b="1">
+                <a:solidFill>
+                  <a:srgbClr val="0F766E"/>
+                </a:solidFill>
+              </a:defRPr>
+            </a:pPr>
+            <a:r>
+              <a:rPr sz="900" b="1">
+                <a:solidFill>
+                  <a:srgbClr val="0F766E"/>
+                </a:solidFill>
+              </a:rPr>
+              <a:t>SYSTEM ARCHITECTURE</a:t>
+            </a:r>
+          </a:p>
+        </p:txBody>
+      </p:sp>
+      <p:sp>
+        <p:nvSpPr>
+          <p:cNvPr id="4" name="architecture-slide-title">
+            <a:extLst xmlns:a="http://schemas.openxmlformats.org/drawingml/2006/main">
+              <a:ext uri="{FF2B5EF4-FFF2-40B4-BE49-F238E27FC236}">
+                <a16:creationId xmlns:a16="http://schemas.microsoft.com/office/drawing/2014/main" id="{A4DFACBB-F0E9-4459-AEC1-E50C85C8B412}"/>
+              </a:ext>
+            </a:extLst>
+          </p:cNvPr>
+          <p:cNvSpPr>
+            <a:spLocks xmlns:a="http://schemas.openxmlformats.org/drawingml/2006/main" noGrp="1"/>
+          </p:cNvSpPr>
+          <p:nvPr/>
+        </p:nvSpPr>
+        <p:spPr>
+          <a:xfrm xmlns:a="http://schemas.openxmlformats.org/drawingml/2006/main">
+            <a:off x="723900" y="742950"/>
+            <a:ext cx="6096000" cy="419100"/>
+          </a:xfrm>
+          <a:prstGeom xmlns:a="http://schemas.openxmlformats.org/drawingml/2006/main" prst="rect">
+            <a:avLst/>
+          </a:prstGeom>
+          <a:noFill xmlns:a="http://schemas.openxmlformats.org/drawingml/2006/main"/>
+          <a:ln xmlns:a="http://schemas.openxmlformats.org/drawingml/2006/main" w="0">
+            <a:noFill/>
+            <a:prstDash val="solid"/>
+          </a:ln>
+        </p:spPr>
+        <p:txBody>
+          <a:bodyPr xmlns:a="http://schemas.openxmlformats.org/drawingml/2006/main"/>
+          <a:lstStyle xmlns:a="http://schemas.openxmlformats.org/drawingml/2006/main"/>
+          <a:p xmlns:a="http://schemas.openxmlformats.org/drawingml/2006/main">
+            <a:pPr>
+              <a:defRPr sz="2100" b="1">
+                <a:solidFill>
+                  <a:srgbClr val="0F172A"/>
+                </a:solidFill>
+              </a:defRPr>
+            </a:pPr>
+            <a:r>
+              <a:rPr sz="2100" b="1">
+                <a:solidFill>
+                  <a:srgbClr val="0F172A"/>
+                </a:solidFill>
+              </a:rPr>
+              <a:t>Maintenance Wizard application architecture</a:t>
+            </a:r>
+          </a:p>
+        </p:txBody>
+      </p:sp>
+      <p:sp>
+        <p:nvSpPr>
+          <p:cNvPr id="5" name="architecture-slide-subtitle">
+            <a:extLst xmlns:a="http://schemas.openxmlformats.org/drawingml/2006/main">
+              <a:ext uri="{FF2B5EF4-FFF2-40B4-BE49-F238E27FC236}">
+                <a16:creationId xmlns:a16="http://schemas.microsoft.com/office/drawing/2014/main" id="{46E34F82-DC0F-4637-A24A-2162F1652B8B}"/>
+              </a:ext>
+            </a:extLst>
+          </p:cNvPr>
+          <p:cNvSpPr>
+            <a:spLocks xmlns:a="http://schemas.openxmlformats.org/drawingml/2006/main" noGrp="1"/>
+          </p:cNvSpPr>
+          <p:nvPr/>
+        </p:nvSpPr>
+        <p:spPr>
+          <a:xfrm xmlns:a="http://schemas.openxmlformats.org/drawingml/2006/main">
+            <a:off x="723900" y="1143000"/>
+            <a:ext cx="8239125" cy="342900"/>
+          </a:xfrm>
+          <a:prstGeom xmlns:a="http://schemas.openxmlformats.org/drawingml/2006/main" prst="rect">
+            <a:avLst/>
+          </a:prstGeom>
+          <a:noFill xmlns:a="http://schemas.openxmlformats.org/drawingml/2006/main"/>
+          <a:ln xmlns:a="http://schemas.openxmlformats.org/drawingml/2006/main" w="0">
+            <a:noFill/>
+            <a:prstDash val="solid"/>
+          </a:ln>
+        </p:spPr>
+        <p:txBody>
+          <a:bodyPr xmlns:a="http://schemas.openxmlformats.org/drawingml/2006/main"/>
+          <a:lstStyle xmlns:a="http://schemas.openxmlformats.org/drawingml/2006/main"/>
+          <a:p xmlns:a="http://schemas.openxmlformats.org/drawingml/2006/main">
+            <a:pPr>
+              <a:defRPr sz="1013">
+                <a:solidFill>
+                  <a:srgbClr val="475569"/>
+                </a:solidFill>
+              </a:defRPr>
+            </a:pPr>
+            <a:r>
+              <a:rPr sz="1013">
+                <a:solidFill>
+                  <a:srgbClr val="475569"/>
+                </a:solidFill>
+              </a:rPr>
+              <a:t>Role-aware UI, deterministic maintenance services, evidence-grounded AI, async workers, RAG storage, and reviewer-controlled learning.</a:t>
+            </a:r>
+          </a:p>
+        </p:txBody>
+      </p:sp>
+      <p:sp>
+        <p:nvSpPr>
+          <p:cNvPr id="6" name="architecture-diagram-frame">
+            <a:extLst xmlns:a="http://schemas.openxmlformats.org/drawingml/2006/main">
+              <a:ext uri="{FF2B5EF4-FFF2-40B4-BE49-F238E27FC236}">
+                <a16:creationId xmlns:a16="http://schemas.microsoft.com/office/drawing/2014/main" id="{B4F1EA95-7C60-40BD-A60A-C94EF0C1CD5F}"/>
+              </a:ext>
+            </a:extLst>
+          </p:cNvPr>
+          <p:cNvSpPr>
+            <a:spLocks xmlns:a="http://schemas.openxmlformats.org/drawingml/2006/main" noGrp="1"/>
+          </p:cNvSpPr>
+          <p:nvPr/>
+        </p:nvSpPr>
+        <p:spPr>
+          <a:xfrm xmlns:a="http://schemas.openxmlformats.org/drawingml/2006/main">
+            <a:off x="695325" y="1581150"/>
+            <a:ext cx="10801350" cy="4533900"/>
+          </a:xfrm>
+          <a:prstGeom xmlns:a="http://schemas.openxmlformats.org/drawingml/2006/main" prst="roundRect">
+            <a:avLst>
+              <a:gd name="adj" fmla="val 2521"/>
+            </a:avLst>
+          </a:prstGeom>
+          <a:solidFill xmlns:a="http://schemas.openxmlformats.org/drawingml/2006/main">
+            <a:srgbClr val="F8FAFC"/>
+          </a:solidFill>
+          <a:ln xmlns:a="http://schemas.openxmlformats.org/drawingml/2006/main" w="9525">
+            <a:solidFill>
+              <a:srgbClr val="CBD5E1"/>
+            </a:solidFill>
+            <a:prstDash val="solid"/>
+          </a:ln>
+        </p:spPr>
+      </p:sp>
+      <p:pic>
+        <p:nvPicPr>
+          <p:cNvPr id="16" name=""/>
+          <p:cNvPicPr>
+            <a:picLocks xmlns:a="http://schemas.openxmlformats.org/drawingml/2006/main" noChangeAspect="1"/>
+          </p:cNvPicPr>
+          <p:nvPr/>
+        </p:nvPicPr>
+        <p:blipFill>
+          <a:blip xmlns:r="http://schemas.openxmlformats.org/officeDocument/2006/relationships" xmlns:a="http://schemas.openxmlformats.org/drawingml/2006/main" r:embed="R42eadc963cb64654"/>
+          <a:srcRect xmlns:a="http://schemas.openxmlformats.org/drawingml/2006/main" l="0" t="17306" r="0" b="17306"/>
+          <a:stretch xmlns:a="http://schemas.openxmlformats.org/drawingml/2006/main">
+            <a:fillRect l="0" t="0" r="0" b="0"/>
+          </a:stretch>
+        </p:blipFill>
+        <p:spPr>
+          <a:xfrm xmlns:a="http://schemas.openxmlformats.org/drawingml/2006/main">
+            <a:off x="828675" y="1695450"/>
+            <a:ext cx="10534650" cy="4305300"/>
+          </a:xfrm>
+          <a:prstGeom xmlns:a="http://schemas.openxmlformats.org/drawingml/2006/main" prst="rect">
+            <a:avLst/>
+          </a:prstGeom>
+        </p:spPr>
+      </p:pic>
+      <p:sp>
+        <p:nvSpPr>
+          <p:cNvPr id="8" name="architecture-slide-caption">
+            <a:extLst xmlns:a="http://schemas.openxmlformats.org/drawingml/2006/main">
+              <a:ext uri="{FF2B5EF4-FFF2-40B4-BE49-F238E27FC236}">
+                <a16:creationId xmlns:a16="http://schemas.microsoft.com/office/drawing/2014/main" id="{2CD7A959-20E2-4AC9-AE11-97CCBF5D04D8}"/>
+              </a:ext>
+            </a:extLst>
+          </p:cNvPr>
+          <p:cNvSpPr>
+            <a:spLocks xmlns:a="http://schemas.openxmlformats.org/drawingml/2006/main" noGrp="1"/>
+          </p:cNvSpPr>
+          <p:nvPr/>
+        </p:nvSpPr>
+        <p:spPr>
+          <a:xfrm xmlns:a="http://schemas.openxmlformats.org/drawingml/2006/main">
+            <a:off x="723900" y="6191250"/>
+            <a:ext cx="10001250" cy="285750"/>
+          </a:xfrm>
+          <a:prstGeom xmlns:a="http://schemas.openxmlformats.org/drawingml/2006/main" prst="rect">
+            <a:avLst/>
+          </a:prstGeom>
+          <a:noFill xmlns:a="http://schemas.openxmlformats.org/drawingml/2006/main"/>
+          <a:ln xmlns:a="http://schemas.openxmlformats.org/drawingml/2006/main" w="0">
+            <a:noFill/>
+            <a:prstDash val="solid"/>
+          </a:ln>
+        </p:spPr>
+        <p:txBody>
+          <a:bodyPr xmlns:a="http://schemas.openxmlformats.org/drawingml/2006/main"/>
+          <a:lstStyle xmlns:a="http://schemas.openxmlformats.org/drawingml/2006/main"/>
+          <a:p xmlns:a="http://schemas.openxmlformats.org/drawingml/2006/main">
+            <a:pPr>
+              <a:defRPr sz="863">
+                <a:solidFill>
+                  <a:srgbClr val="64748B"/>
+                </a:solidFill>
+              </a:defRPr>
+            </a:pPr>
+            <a:r>
+              <a:rPr sz="863">
+                <a:solidFill>
+                  <a:srgbClr val="64748B"/>
+                </a:solidFill>
+              </a:rPr>
+              <a:t>Diagram view: plant channels -&gt; React workflows -&gt; FastAPI/RBAC -&gt; deterministic services -&gt; AI/RAG/learning -&gt; operational data stores.</a:t>
+            </a:r>
+          </a:p>
+        </p:txBody>
+      </p:sp>
+      <p:sp>
+        <p:nvSpPr>
+          <p:cNvPr id="9" name="architecture-slide-marker">
+            <a:extLst xmlns:a="http://schemas.openxmlformats.org/drawingml/2006/main">
+              <a:ext uri="{FF2B5EF4-FFF2-40B4-BE49-F238E27FC236}">
+                <a16:creationId xmlns:a16="http://schemas.microsoft.com/office/drawing/2014/main" id="{02EF7AB0-A2AD-4C91-8E05-366560F4BA33}"/>
+              </a:ext>
+            </a:extLst>
+          </p:cNvPr>
+          <p:cNvSpPr>
+            <a:spLocks xmlns:a="http://schemas.openxmlformats.org/drawingml/2006/main" noGrp="1"/>
+          </p:cNvSpPr>
+          <p:nvPr/>
+        </p:nvSpPr>
+        <p:spPr>
+          <a:xfrm xmlns:a="http://schemas.openxmlformats.org/drawingml/2006/main">
+            <a:off x="11010900" y="495300"/>
+            <a:ext cx="476250" cy="266700"/>
+          </a:xfrm>
+          <a:prstGeom xmlns:a="http://schemas.openxmlformats.org/drawingml/2006/main" prst="roundRect">
+            <a:avLst>
+              <a:gd name="adj" fmla="val 50000"/>
+            </a:avLst>
+          </a:prstGeom>
+          <a:solidFill xmlns:a="http://schemas.openxmlformats.org/drawingml/2006/main">
+            <a:srgbClr val="E0F2FE"/>
+          </a:solidFill>
+          <a:ln xmlns:a="http://schemas.openxmlformats.org/drawingml/2006/main" w="9525">
+            <a:solidFill>
+              <a:srgbClr val="BAE6FD"/>
+            </a:solidFill>
+            <a:prstDash val="solid"/>
+          </a:ln>
+        </p:spPr>
+        <p:txBody>
+          <a:bodyPr xmlns:a="http://schemas.openxmlformats.org/drawingml/2006/main"/>
+          <a:lstStyle xmlns:a="http://schemas.openxmlformats.org/drawingml/2006/main"/>
+          <a:p xmlns:a="http://schemas.openxmlformats.org/drawingml/2006/main">
+            <a:pPr algn="ctr">
+              <a:defRPr sz="900" b="1">
+                <a:solidFill>
+                  <a:srgbClr val="075985"/>
+                </a:solidFill>
+              </a:defRPr>
+            </a:pPr>
+            <a:r>
+              <a:rPr sz="900" b="1">
+                <a:solidFill>
+                  <a:srgbClr val="075985"/>
+                </a:solidFill>
+              </a:rPr>
+              <a:t>13</a:t>
+            </a:r>
+          </a:p>
+        </p:txBody>
+      </p:sp>
+    </p:spTree>
+    <p:extLst>
+      <p:ext uri="{BB962C8B-B14F-4D97-AF65-F5344CB8AC3E}">
+        <p14:creationId xmlns:p14="http://schemas.microsoft.com/office/powerpoint/2010/main" val="1464376454"/>
       </p:ext>
     </p:extLst>
   </p:cSld>
@@ -13603,17 +14114,17 @@
       </p:sp>
       <p:pic>
         <p:nvPicPr>
-          <p:cNvPr id="22" name=""/>
+          <p:cNvPr id="66" name=""/>
           <p:cNvPicPr>
             <a:picLocks xmlns:a="http://schemas.openxmlformats.org/drawingml/2006/main" noChangeAspect="1"/>
           </p:cNvPicPr>
           <p:nvPr/>
         </p:nvPicPr>
         <p:blipFill>
-          <a:blip xmlns:r="http://schemas.openxmlformats.org/officeDocument/2006/relationships" xmlns:a="http://schemas.openxmlformats.org/drawingml/2006/main" r:embed="Rea4f239c98b943db">
+          <a:blip xmlns:r="http://schemas.openxmlformats.org/officeDocument/2006/relationships" xmlns:a="http://schemas.openxmlformats.org/drawingml/2006/main" r:embed="R469a60e668d945a8">
             <a:extLst>
               <a:ext uri="{96DAC541-7B7A-43D3-8B79-37D633B846F1}">
-                <asvg:svgBlip xmlns:asvg="http://schemas.microsoft.com/office/drawing/2016/SVG/main" r:embed="Ra5b93f6897644b94"/>
+                <asvg:svgBlip xmlns:asvg="http://schemas.microsoft.com/office/drawing/2016/SVG/main" r:embed="Re66483bd3106435b"/>
               </a:ext>
             </a:extLst>
           </a:blip>
@@ -13926,17 +14437,17 @@
       </p:sp>
       <p:pic>
         <p:nvPicPr>
-          <p:cNvPr id="28" name=""/>
+          <p:cNvPr id="72" name=""/>
           <p:cNvPicPr>
             <a:picLocks xmlns:a="http://schemas.openxmlformats.org/drawingml/2006/main" noChangeAspect="1"/>
           </p:cNvPicPr>
           <p:nvPr/>
         </p:nvPicPr>
         <p:blipFill>
-          <a:blip xmlns:r="http://schemas.openxmlformats.org/officeDocument/2006/relationships" xmlns:a="http://schemas.openxmlformats.org/drawingml/2006/main" r:embed="R68c1f283ed0b40e9">
+          <a:blip xmlns:r="http://schemas.openxmlformats.org/officeDocument/2006/relationships" xmlns:a="http://schemas.openxmlformats.org/drawingml/2006/main" r:embed="Rad13bd061ab64b40">
             <a:extLst>
               <a:ext uri="{96DAC541-7B7A-43D3-8B79-37D633B846F1}">
-                <asvg:svgBlip xmlns:asvg="http://schemas.microsoft.com/office/drawing/2016/SVG/main" r:embed="R3effaa6159b24888"/>
+                <asvg:svgBlip xmlns:asvg="http://schemas.microsoft.com/office/drawing/2016/SVG/main" r:embed="R4f04bffab8854b05"/>
               </a:ext>
             </a:extLst>
           </a:blip>
@@ -14249,17 +14760,17 @@
       </p:sp>
       <p:pic>
         <p:nvPicPr>
-          <p:cNvPr id="34" name=""/>
+          <p:cNvPr id="78" name=""/>
           <p:cNvPicPr>
             <a:picLocks xmlns:a="http://schemas.openxmlformats.org/drawingml/2006/main" noChangeAspect="1"/>
           </p:cNvPicPr>
           <p:nvPr/>
         </p:nvPicPr>
         <p:blipFill>
-          <a:blip xmlns:r="http://schemas.openxmlformats.org/officeDocument/2006/relationships" xmlns:a="http://schemas.openxmlformats.org/drawingml/2006/main" r:embed="R6818861066364fa3">
+          <a:blip xmlns:r="http://schemas.openxmlformats.org/officeDocument/2006/relationships" xmlns:a="http://schemas.openxmlformats.org/drawingml/2006/main" r:embed="R62fd0f153b4f46d6">
             <a:extLst>
               <a:ext uri="{96DAC541-7B7A-43D3-8B79-37D633B846F1}">
-                <asvg:svgBlip xmlns:asvg="http://schemas.microsoft.com/office/drawing/2016/SVG/main" r:embed="R281936e0d38c4e59"/>
+                <asvg:svgBlip xmlns:asvg="http://schemas.microsoft.com/office/drawing/2016/SVG/main" r:embed="R93ee8d43a5b342cd"/>
               </a:ext>
             </a:extLst>
           </a:blip>

</xml_diff>

<commit_message>
Show full architecture diagram in deck
</commit_message>
<xml_diff>
--- a/docs/decks/maintenance-wizard-ai-capabilities-hackathon-objectives.pptx
+++ b/docs/decks/maintenance-wizard-ai-capabilities-hackathon-objectives.pptx
@@ -2,25 +2,25 @@
 <file path=ppt/presentation.xml><?xml version="1.0" encoding="utf-8"?>
 <p:presentation xmlns:p="http://schemas.openxmlformats.org/presentationml/2006/main">
   <p:sldMasterIdLst>
-    <p:sldMasterId xmlns:r="http://schemas.openxmlformats.org/officeDocument/2006/relationships" id="2147483648" r:id="R536921ac05de48cb"/>
+    <p:sldMasterId xmlns:r="http://schemas.openxmlformats.org/officeDocument/2006/relationships" id="2147483648" r:id="R735af196dcbf4367"/>
   </p:sldMasterIdLst>
   <p:notesMasterIdLst>
-    <p:notesMasterId xmlns:r="http://schemas.openxmlformats.org/officeDocument/2006/relationships" r:id="R835ceb4fcd7d45f1"/>
+    <p:notesMasterId xmlns:r="http://schemas.openxmlformats.org/officeDocument/2006/relationships" r:id="R98783e528ffc4685"/>
   </p:notesMasterIdLst>
   <p:sldIdLst>
-    <p:sldId xmlns:r="http://schemas.openxmlformats.org/officeDocument/2006/relationships" id="256" r:id="R7a4671d66fed4f14"/>
-    <p:sldId xmlns:r="http://schemas.openxmlformats.org/officeDocument/2006/relationships" id="257" r:id="R769ffc4514664800"/>
-    <p:sldId xmlns:r="http://schemas.openxmlformats.org/officeDocument/2006/relationships" id="258" r:id="Rf1770f797e414c83"/>
-    <p:sldId xmlns:r="http://schemas.openxmlformats.org/officeDocument/2006/relationships" id="259" r:id="R1c8e9d975e544f6e"/>
-    <p:sldId xmlns:r="http://schemas.openxmlformats.org/officeDocument/2006/relationships" id="260" r:id="R3dbd7db5a21841df"/>
-    <p:sldId xmlns:r="http://schemas.openxmlformats.org/officeDocument/2006/relationships" id="261" r:id="R65315dfd64d3479c"/>
-    <p:sldId xmlns:r="http://schemas.openxmlformats.org/officeDocument/2006/relationships" id="262" r:id="R2325d287ff904877"/>
-    <p:sldId xmlns:r="http://schemas.openxmlformats.org/officeDocument/2006/relationships" id="263" r:id="R3d03ddb83ee44749"/>
-    <p:sldId xmlns:r="http://schemas.openxmlformats.org/officeDocument/2006/relationships" id="264" r:id="R84123f2b4e5d438a"/>
-    <p:sldId xmlns:r="http://schemas.openxmlformats.org/officeDocument/2006/relationships" id="265" r:id="Rfef044d7119d4a47"/>
-    <p:sldId xmlns:r="http://schemas.openxmlformats.org/officeDocument/2006/relationships" id="266" r:id="Ra53f5be9797140c1"/>
-    <p:sldId xmlns:r="http://schemas.openxmlformats.org/officeDocument/2006/relationships" id="267" r:id="R9b86ed917c8f4458"/>
-    <p:sldId xmlns:r="http://schemas.openxmlformats.org/officeDocument/2006/relationships" id="268" r:id="R41d55a32c17d4c17"/>
+    <p:sldId xmlns:r="http://schemas.openxmlformats.org/officeDocument/2006/relationships" id="256" r:id="R6df3604da1674032"/>
+    <p:sldId xmlns:r="http://schemas.openxmlformats.org/officeDocument/2006/relationships" id="257" r:id="Rf25999f45f80434d"/>
+    <p:sldId xmlns:r="http://schemas.openxmlformats.org/officeDocument/2006/relationships" id="258" r:id="R6a532485bb094a88"/>
+    <p:sldId xmlns:r="http://schemas.openxmlformats.org/officeDocument/2006/relationships" id="259" r:id="R0b61e878d6e14878"/>
+    <p:sldId xmlns:r="http://schemas.openxmlformats.org/officeDocument/2006/relationships" id="260" r:id="Ra78da984f7b54a03"/>
+    <p:sldId xmlns:r="http://schemas.openxmlformats.org/officeDocument/2006/relationships" id="261" r:id="R68ce4d04273c4d95"/>
+    <p:sldId xmlns:r="http://schemas.openxmlformats.org/officeDocument/2006/relationships" id="262" r:id="R120b829d9c8940c8"/>
+    <p:sldId xmlns:r="http://schemas.openxmlformats.org/officeDocument/2006/relationships" id="263" r:id="R1577a681aed24014"/>
+    <p:sldId xmlns:r="http://schemas.openxmlformats.org/officeDocument/2006/relationships" id="264" r:id="Rcc32263012d34858"/>
+    <p:sldId xmlns:r="http://schemas.openxmlformats.org/officeDocument/2006/relationships" id="265" r:id="R2b6bfe62453b461b"/>
+    <p:sldId xmlns:r="http://schemas.openxmlformats.org/officeDocument/2006/relationships" id="266" r:id="Rb9af2f7a0bf34c38"/>
+    <p:sldId xmlns:r="http://schemas.openxmlformats.org/officeDocument/2006/relationships" id="267" r:id="R30be59f7a0694a61"/>
+    <p:sldId xmlns:r="http://schemas.openxmlformats.org/officeDocument/2006/relationships" id="268" r:id="R132e8c1fe1214188"/>
   </p:sldIdLst>
   <p:sldSz cx="12192000" cy="6858000"/>
   <p:notesSz cx="6858000" cy="9144000"/>
@@ -1359,7 +1359,7 @@
   </p:cSld>
   <p:clrMap bg1="lt1" tx1="dk1" bg2="lt2" tx2="dk2" accent1="accent1" accent2="accent2" accent3="accent3" accent4="accent4" accent5="accent5" accent6="accent6" hlink="hlink" folHlink="folHlink"/>
   <p:sldLayoutIdLst>
-    <p:sldLayoutId xmlns:r="http://schemas.openxmlformats.org/officeDocument/2006/relationships" id="2147483649" r:id="R6d75ea268f8a4e4d"/>
+    <p:sldLayoutId xmlns:r="http://schemas.openxmlformats.org/officeDocument/2006/relationships" id="2147483649" r:id="R7aab90059acd4728"/>
   </p:sldLayoutIdLst>
   <p:txStyles>
     <p:titleStyle>
@@ -12982,6 +12982,7 @@
           <a:lstStyle xmlns:a="http://schemas.openxmlformats.org/drawingml/2006/main"/>
           <a:p xmlns:a="http://schemas.openxmlformats.org/drawingml/2006/main">
             <a:pPr>
+              <a:buNone/>
               <a:defRPr sz="900" b="1">
                 <a:solidFill>
                   <a:srgbClr val="0F766E"/>
@@ -13032,6 +13033,7 @@
           <a:lstStyle xmlns:a="http://schemas.openxmlformats.org/drawingml/2006/main"/>
           <a:p xmlns:a="http://schemas.openxmlformats.org/drawingml/2006/main">
             <a:pPr>
+              <a:buNone/>
               <a:defRPr sz="2100" b="1">
                 <a:solidFill>
                   <a:srgbClr val="0F172A"/>
@@ -13082,6 +13084,7 @@
           <a:lstStyle xmlns:a="http://schemas.openxmlformats.org/drawingml/2006/main"/>
           <a:p xmlns:a="http://schemas.openxmlformats.org/drawingml/2006/main">
             <a:pPr>
+              <a:buNone/>
               <a:defRPr sz="1013">
                 <a:solidFill>
                   <a:srgbClr val="475569"/>
@@ -13136,23 +13139,23 @@
       </p:sp>
       <p:pic>
         <p:nvPicPr>
-          <p:cNvPr id="16" name=""/>
+          <p:cNvPr id="19" name=""/>
           <p:cNvPicPr>
             <a:picLocks xmlns:a="http://schemas.openxmlformats.org/drawingml/2006/main" noChangeAspect="1"/>
           </p:cNvPicPr>
           <p:nvPr/>
         </p:nvPicPr>
         <p:blipFill>
-          <a:blip xmlns:r="http://schemas.openxmlformats.org/officeDocument/2006/relationships" xmlns:a="http://schemas.openxmlformats.org/drawingml/2006/main" r:embed="R42eadc963cb64654"/>
-          <a:srcRect xmlns:a="http://schemas.openxmlformats.org/drawingml/2006/main" l="0" t="17306" r="0" b="17306"/>
+          <a:blip xmlns:r="http://schemas.openxmlformats.org/officeDocument/2006/relationships" xmlns:a="http://schemas.openxmlformats.org/drawingml/2006/main" r:embed="Rb93ed529f60741d7"/>
+          <a:srcRect xmlns:a="http://schemas.openxmlformats.org/drawingml/2006/main" l="0" t="0" r="0" b="0"/>
           <a:stretch xmlns:a="http://schemas.openxmlformats.org/drawingml/2006/main">
             <a:fillRect l="0" t="0" r="0" b="0"/>
           </a:stretch>
         </p:blipFill>
         <p:spPr>
           <a:xfrm xmlns:a="http://schemas.openxmlformats.org/drawingml/2006/main">
-            <a:off x="828675" y="1695450"/>
-            <a:ext cx="10534650" cy="4305300"/>
+            <a:off x="0" y="0"/>
+            <a:ext cx="12192000" cy="6858000"/>
           </a:xfrm>
           <a:prstGeom xmlns:a="http://schemas.openxmlformats.org/drawingml/2006/main" prst="rect">
             <a:avLst/>
@@ -13192,6 +13195,7 @@
           <a:lstStyle xmlns:a="http://schemas.openxmlformats.org/drawingml/2006/main"/>
           <a:p xmlns:a="http://schemas.openxmlformats.org/drawingml/2006/main">
             <a:pPr>
+              <a:buNone/>
               <a:defRPr sz="863">
                 <a:solidFill>
                   <a:srgbClr val="64748B"/>
@@ -13248,6 +13252,7 @@
           <a:lstStyle xmlns:a="http://schemas.openxmlformats.org/drawingml/2006/main"/>
           <a:p xmlns:a="http://schemas.openxmlformats.org/drawingml/2006/main">
             <a:pPr algn="ctr">
+              <a:buNone/>
               <a:defRPr sz="900" b="1">
                 <a:solidFill>
                   <a:srgbClr val="075985"/>
@@ -13265,6 +13270,59 @@
           </a:p>
         </p:txBody>
       </p:sp>
+      <p:sp>
+        <p:nvSpPr>
+          <p:cNvPr id="11" name="architecture-full-image-clean-background">
+            <a:extLst xmlns:a="http://schemas.openxmlformats.org/drawingml/2006/main">
+              <a:ext uri="{FF2B5EF4-FFF2-40B4-BE49-F238E27FC236}">
+                <a16:creationId xmlns:a16="http://schemas.microsoft.com/office/drawing/2014/main" id="{CABC95C2-1719-46BA-AC98-4455A38D8906}"/>
+              </a:ext>
+            </a:extLst>
+          </p:cNvPr>
+          <p:cNvSpPr>
+            <a:spLocks xmlns:a="http://schemas.openxmlformats.org/drawingml/2006/main" noGrp="1"/>
+          </p:cNvSpPr>
+          <p:nvPr/>
+        </p:nvSpPr>
+        <p:spPr>
+          <a:xfrm xmlns:a="http://schemas.openxmlformats.org/drawingml/2006/main">
+            <a:off x="0" y="0"/>
+            <a:ext cx="12192000" cy="6858000"/>
+          </a:xfrm>
+          <a:prstGeom xmlns:a="http://schemas.openxmlformats.org/drawingml/2006/main" prst="rect">
+            <a:avLst/>
+          </a:prstGeom>
+          <a:solidFill xmlns:a="http://schemas.openxmlformats.org/drawingml/2006/main">
+            <a:srgbClr val="F6FBFF"/>
+          </a:solidFill>
+          <a:ln xmlns:a="http://schemas.openxmlformats.org/drawingml/2006/main" w="0">
+            <a:noFill/>
+            <a:prstDash val="solid"/>
+          </a:ln>
+        </p:spPr>
+      </p:sp>
+      <p:pic>
+        <p:nvPicPr>
+          <p:cNvPr id="23" name=""/>
+          <p:cNvPicPr>
+            <a:picLocks xmlns:a="http://schemas.openxmlformats.org/drawingml/2006/main" noChangeAspect="1"/>
+          </p:cNvPicPr>
+          <p:nvPr/>
+        </p:nvPicPr>
+        <p:blipFill>
+          <a:blip xmlns:r="http://schemas.openxmlformats.org/officeDocument/2006/relationships" xmlns:a="http://schemas.openxmlformats.org/drawingml/2006/main" r:embed="Rd852489dcff3440f"/>
+          <a:stretch xmlns:a="http://schemas.openxmlformats.org/drawingml/2006/main"/>
+        </p:blipFill>
+        <p:spPr>
+          <a:xfrm xmlns:a="http://schemas.openxmlformats.org/drawingml/2006/main">
+            <a:off x="609600" y="0"/>
+            <a:ext cx="10972800" cy="6858000"/>
+          </a:xfrm>
+          <a:prstGeom xmlns:a="http://schemas.openxmlformats.org/drawingml/2006/main" prst="rect">
+            <a:avLst/>
+          </a:prstGeom>
+        </p:spPr>
+      </p:pic>
     </p:spTree>
     <p:extLst>
       <p:ext uri="{BB962C8B-B14F-4D97-AF65-F5344CB8AC3E}">
@@ -14121,10 +14179,10 @@
           <p:nvPr/>
         </p:nvPicPr>
         <p:blipFill>
-          <a:blip xmlns:r="http://schemas.openxmlformats.org/officeDocument/2006/relationships" xmlns:a="http://schemas.openxmlformats.org/drawingml/2006/main" r:embed="R469a60e668d945a8">
+          <a:blip xmlns:r="http://schemas.openxmlformats.org/officeDocument/2006/relationships" xmlns:a="http://schemas.openxmlformats.org/drawingml/2006/main" r:embed="R31119b298e214fda">
             <a:extLst>
               <a:ext uri="{96DAC541-7B7A-43D3-8B79-37D633B846F1}">
-                <asvg:svgBlip xmlns:asvg="http://schemas.microsoft.com/office/drawing/2016/SVG/main" r:embed="Re66483bd3106435b"/>
+                <asvg:svgBlip xmlns:asvg="http://schemas.microsoft.com/office/drawing/2016/SVG/main" r:embed="Ra0f1e14848e14be8"/>
               </a:ext>
             </a:extLst>
           </a:blip>
@@ -14444,10 +14502,10 @@
           <p:nvPr/>
         </p:nvPicPr>
         <p:blipFill>
-          <a:blip xmlns:r="http://schemas.openxmlformats.org/officeDocument/2006/relationships" xmlns:a="http://schemas.openxmlformats.org/drawingml/2006/main" r:embed="Rad13bd061ab64b40">
+          <a:blip xmlns:r="http://schemas.openxmlformats.org/officeDocument/2006/relationships" xmlns:a="http://schemas.openxmlformats.org/drawingml/2006/main" r:embed="R943966c51e6f42db">
             <a:extLst>
               <a:ext uri="{96DAC541-7B7A-43D3-8B79-37D633B846F1}">
-                <asvg:svgBlip xmlns:asvg="http://schemas.microsoft.com/office/drawing/2016/SVG/main" r:embed="R4f04bffab8854b05"/>
+                <asvg:svgBlip xmlns:asvg="http://schemas.microsoft.com/office/drawing/2016/SVG/main" r:embed="R0d9894829107406f"/>
               </a:ext>
             </a:extLst>
           </a:blip>
@@ -14767,10 +14825,10 @@
           <p:nvPr/>
         </p:nvPicPr>
         <p:blipFill>
-          <a:blip xmlns:r="http://schemas.openxmlformats.org/officeDocument/2006/relationships" xmlns:a="http://schemas.openxmlformats.org/drawingml/2006/main" r:embed="R62fd0f153b4f46d6">
+          <a:blip xmlns:r="http://schemas.openxmlformats.org/officeDocument/2006/relationships" xmlns:a="http://schemas.openxmlformats.org/drawingml/2006/main" r:embed="R1f8f16f7c7d04d90">
             <a:extLst>
               <a:ext uri="{96DAC541-7B7A-43D3-8B79-37D633B846F1}">
-                <asvg:svgBlip xmlns:asvg="http://schemas.microsoft.com/office/drawing/2016/SVG/main" r:embed="R93ee8d43a5b342cd"/>
+                <asvg:svgBlip xmlns:asvg="http://schemas.microsoft.com/office/drawing/2016/SVG/main" r:embed="Refd8c37a9d604b24"/>
               </a:ext>
             </a:extLst>
           </a:blip>
@@ -15974,8 +16032,8 @@
         </p:nvSpPr>
         <p:spPr>
           <a:xfrm xmlns:a="http://schemas.openxmlformats.org/drawingml/2006/main">
-            <a:off x="685800" y="1962150"/>
-            <a:ext cx="8096250" cy="628650"/>
+            <a:off x="0" y="6858000"/>
+            <a:ext cx="9525" cy="9525"/>
           </a:xfrm>
           <a:prstGeom xmlns:a="http://schemas.openxmlformats.org/drawingml/2006/main" prst="rect">
             <a:avLst/>
@@ -16018,7 +16076,7 @@
                 <a:ea typeface="Aptos"/>
                 <a:cs typeface="Aptos"/>
               </a:rPr>
-              <a:t>The backend keeps raw ingestion, auth, risk/RUL scoring, persistence, and status transitions deterministic while the model explains, classifies, retrieves, drafts, reranks, and judges.</a:t>
+              <a:t/>
             </a:r>
           </a:p>
         </p:txBody>
@@ -16039,8 +16097,8 @@
         </p:nvSpPr>
         <p:spPr>
           <a:xfrm xmlns:a="http://schemas.openxmlformats.org/drawingml/2006/main">
-            <a:off x="704850" y="2971800"/>
-            <a:ext cx="1714500" cy="1581150"/>
+            <a:off x="0" y="6858000"/>
+            <a:ext cx="9525" cy="9525"/>
           </a:xfrm>
           <a:prstGeom xmlns:a="http://schemas.openxmlformats.org/drawingml/2006/main" prst="roundRect">
             <a:avLst>
@@ -16057,6 +16115,15 @@
             <a:prstDash val="solid"/>
           </a:ln>
         </p:spPr>
+        <p:txBody>
+          <a:bodyPr xmlns:a="http://schemas.openxmlformats.org/drawingml/2006/main"/>
+          <a:lstStyle xmlns:a="http://schemas.openxmlformats.org/drawingml/2006/main"/>
+          <a:p xmlns:a="http://schemas.openxmlformats.org/drawingml/2006/main">
+            <a:r>
+              <a:t/>
+            </a:r>
+          </a:p>
+        </p:txBody>
       </p:sp>
       <p:sp>
         <p:nvSpPr>

</xml_diff>

<commit_message>
Align docs and judge live LLM handling
</commit_message>
<xml_diff>
--- a/docs/decks/maintenance-wizard-ai-capabilities-hackathon-objectives.pptx
+++ b/docs/decks/maintenance-wizard-ai-capabilities-hackathon-objectives.pptx
@@ -6254,7 +6254,7 @@
                 <a:ea typeface="Aptos"/>
                 <a:cs typeface="Aptos"/>
               </a:rPr>
-              <a:t>LM Studio + Qwen2.5 7B Instruct GGUF</a:t>
+              <a:t>llama.cpp Qwen2.5 7B + LoRA adapter</a:t>
             </a:r>
           </a:p>
         </p:txBody>
@@ -14130,7 +14130,7 @@
                 <a:ea typeface="Aptos"/>
                 <a:cs typeface="Aptos"/>
               </a:rPr>
-              <a:t>Each assistant is grounded by the same app context, role checks, provider adapter, retrieval layer, and deterministic fallback path.</a:t>
+              <a:t>Each assistant is grounded by the same app context, role checks, provider adapter, retrieval layer, streaming contract, and deterministic guardrails.</a:t>
             </a:r>
           </a:p>
         </p:txBody>
@@ -19083,7 +19083,7 @@
                 <a:ea typeface="Aptos"/>
                 <a:cs typeface="Aptos"/>
               </a:rPr>
-              <a:t>Document chunks and approved learning examples retrieved into prompts with asset context.</a:t>
+              <a:t>Document chunks, approved learning examples, and indexed plant records retrieved into prompts with asset context.</a:t>
             </a:r>
           </a:p>
         </p:txBody>
@@ -26992,7 +26992,7 @@
                 <a:ea typeface="Aptos"/>
                 <a:cs typeface="Aptos"/>
               </a:rPr>
-              <a:t>fallback if invalid</a:t>
+              <a:t>validated or explicit error</a:t>
             </a:r>
           </a:p>
         </p:txBody>
@@ -33039,7 +33039,7 @@
                 <a:ea typeface="Aptos"/>
                 <a:cs typeface="Aptos"/>
               </a:rPr>
-              <a:t>Structured JSON + fallback</a:t>
+              <a:t>Readable streams + schemas</a:t>
             </a:r>
           </a:p>
         </p:txBody>

</xml_diff>

<commit_message>
Update runtime and monitoring docs
</commit_message>
<xml_diff>
--- a/docs/decks/maintenance-wizard-ai-capabilities-hackathon-objectives.pptx
+++ b/docs/decks/maintenance-wizard-ai-capabilities-hackathon-objectives.pptx
@@ -2,25 +2,25 @@
 <file path=ppt/presentation.xml><?xml version="1.0" encoding="utf-8"?>
 <p:presentation xmlns:p="http://schemas.openxmlformats.org/presentationml/2006/main">
   <p:sldMasterIdLst>
-    <p:sldMasterId xmlns:r="http://schemas.openxmlformats.org/officeDocument/2006/relationships" id="2147483648" r:id="R735af196dcbf4367"/>
+    <p:sldMasterId xmlns:r="http://schemas.openxmlformats.org/officeDocument/2006/relationships" id="2147483648" r:id="R67c54dfa8aa4439e"/>
   </p:sldMasterIdLst>
   <p:notesMasterIdLst>
-    <p:notesMasterId xmlns:r="http://schemas.openxmlformats.org/officeDocument/2006/relationships" r:id="R98783e528ffc4685"/>
+    <p:notesMasterId xmlns:r="http://schemas.openxmlformats.org/officeDocument/2006/relationships" r:id="Rd4ec280f619843ad"/>
   </p:notesMasterIdLst>
   <p:sldIdLst>
-    <p:sldId xmlns:r="http://schemas.openxmlformats.org/officeDocument/2006/relationships" id="256" r:id="R6df3604da1674032"/>
-    <p:sldId xmlns:r="http://schemas.openxmlformats.org/officeDocument/2006/relationships" id="257" r:id="Rf25999f45f80434d"/>
-    <p:sldId xmlns:r="http://schemas.openxmlformats.org/officeDocument/2006/relationships" id="258" r:id="R6a532485bb094a88"/>
-    <p:sldId xmlns:r="http://schemas.openxmlformats.org/officeDocument/2006/relationships" id="259" r:id="R0b61e878d6e14878"/>
-    <p:sldId xmlns:r="http://schemas.openxmlformats.org/officeDocument/2006/relationships" id="260" r:id="Ra78da984f7b54a03"/>
-    <p:sldId xmlns:r="http://schemas.openxmlformats.org/officeDocument/2006/relationships" id="261" r:id="R68ce4d04273c4d95"/>
-    <p:sldId xmlns:r="http://schemas.openxmlformats.org/officeDocument/2006/relationships" id="262" r:id="R120b829d9c8940c8"/>
-    <p:sldId xmlns:r="http://schemas.openxmlformats.org/officeDocument/2006/relationships" id="263" r:id="R1577a681aed24014"/>
-    <p:sldId xmlns:r="http://schemas.openxmlformats.org/officeDocument/2006/relationships" id="264" r:id="Rcc32263012d34858"/>
-    <p:sldId xmlns:r="http://schemas.openxmlformats.org/officeDocument/2006/relationships" id="265" r:id="R2b6bfe62453b461b"/>
-    <p:sldId xmlns:r="http://schemas.openxmlformats.org/officeDocument/2006/relationships" id="266" r:id="Rb9af2f7a0bf34c38"/>
-    <p:sldId xmlns:r="http://schemas.openxmlformats.org/officeDocument/2006/relationships" id="267" r:id="R30be59f7a0694a61"/>
-    <p:sldId xmlns:r="http://schemas.openxmlformats.org/officeDocument/2006/relationships" id="268" r:id="R132e8c1fe1214188"/>
+    <p:sldId xmlns:r="http://schemas.openxmlformats.org/officeDocument/2006/relationships" id="256" r:id="R1ea84dd5cfaa4175"/>
+    <p:sldId xmlns:r="http://schemas.openxmlformats.org/officeDocument/2006/relationships" id="257" r:id="Ra97f56e0373c470d"/>
+    <p:sldId xmlns:r="http://schemas.openxmlformats.org/officeDocument/2006/relationships" id="258" r:id="Rcd35675efc3649fa"/>
+    <p:sldId xmlns:r="http://schemas.openxmlformats.org/officeDocument/2006/relationships" id="259" r:id="R66038532a7904761"/>
+    <p:sldId xmlns:r="http://schemas.openxmlformats.org/officeDocument/2006/relationships" id="260" r:id="R4f7bb3e6766f4e2c"/>
+    <p:sldId xmlns:r="http://schemas.openxmlformats.org/officeDocument/2006/relationships" id="261" r:id="R887f1a9cf5314860"/>
+    <p:sldId xmlns:r="http://schemas.openxmlformats.org/officeDocument/2006/relationships" id="262" r:id="Rfe58eed9aa224417"/>
+    <p:sldId xmlns:r="http://schemas.openxmlformats.org/officeDocument/2006/relationships" id="263" r:id="R6746a545ccd6456f"/>
+    <p:sldId xmlns:r="http://schemas.openxmlformats.org/officeDocument/2006/relationships" id="264" r:id="R8705718566604237"/>
+    <p:sldId xmlns:r="http://schemas.openxmlformats.org/officeDocument/2006/relationships" id="265" r:id="R7ce29a323682470b"/>
+    <p:sldId xmlns:r="http://schemas.openxmlformats.org/officeDocument/2006/relationships" id="266" r:id="R7ca0bccb2e5d4fe6"/>
+    <p:sldId xmlns:r="http://schemas.openxmlformats.org/officeDocument/2006/relationships" id="267" r:id="Rb79d0ecdd68a48f8"/>
+    <p:sldId xmlns:r="http://schemas.openxmlformats.org/officeDocument/2006/relationships" id="268" r:id="Rb83c51b02d0647ca"/>
   </p:sldIdLst>
   <p:sldSz cx="12192000" cy="6858000"/>
   <p:notesSz cx="6858000" cy="9144000"/>
@@ -1359,7 +1359,7 @@
   </p:cSld>
   <p:clrMap bg1="lt1" tx1="dk1" bg2="lt2" tx2="dk2" accent1="accent1" accent2="accent2" accent3="accent3" accent4="accent4" accent5="accent5" accent6="accent6" hlink="hlink" folHlink="folHlink"/>
   <p:sldLayoutIdLst>
-    <p:sldLayoutId xmlns:r="http://schemas.openxmlformats.org/officeDocument/2006/relationships" id="2147483649" r:id="R7aab90059acd4728"/>
+    <p:sldLayoutId xmlns:r="http://schemas.openxmlformats.org/officeDocument/2006/relationships" id="2147483649" r:id="R42c146aad33f4442"/>
   </p:sldLayoutIdLst>
   <p:txStyles>
     <p:titleStyle>
@@ -2572,7 +2572,7 @@
                 <a:ea typeface="Aptos Display"/>
                 <a:cs typeface="Aptos Display"/>
               </a:rPr>
-              <a:t>Maintenance Wizard turns plant evidence into governed AI action.</a:t>
+              <a:t>Maintenance Wizard turns plant evidence, live IoT telemetry, and adapter-backed AI into governed action.</a:t>
             </a:r>
           </a:p>
         </p:txBody>
@@ -2637,7 +2637,7 @@
                 <a:ea typeface="Aptos"/>
                 <a:cs typeface="Aptos"/>
               </a:rPr>
-              <a:t>Neo, Morpheus, and Smith sit on top of deterministic maintenance services: ingestion, retrieval, risk, prediction, work orders, learning review, and reports.</a:t>
+              <a:t>Neo, Trinity, Morpheus, and Smith run on deterministic services plus llama-server adapter serving: ingestion, monitoring, retrieval, risk, prediction, work orders, learning review, and reports.</a:t>
             </a:r>
           </a:p>
         </p:txBody>
@@ -3562,7 +3562,7 @@
                 <a:ea typeface="Aptos Mono"/>
                 <a:cs typeface="Aptos Mono"/>
               </a:rPr>
-              <a:t>3</a:t>
+              <a:t>4</a:t>
             </a:r>
           </a:p>
         </p:txBody>
@@ -3627,7 +3627,7 @@
                 <a:ea typeface="Aptos"/>
                 <a:cs typeface="Aptos"/>
               </a:rPr>
-              <a:t>assistant personas: Neo, Morpheus, Smith</a:t>
+              <a:t>assistant personas: Neo, Trinity, Morpheus, Smith</a:t>
             </a:r>
           </a:p>
         </p:txBody>
@@ -3892,7 +3892,7 @@
                 <a:ea typeface="Aptos Mono"/>
                 <a:cs typeface="Aptos Mono"/>
               </a:rPr>
-              <a:t>4</a:t>
+              <a:t>5</a:t>
             </a:r>
           </a:p>
         </p:txBody>
@@ -3957,7 +3957,7 @@
                 <a:ea typeface="Aptos"/>
                 <a:cs typeface="Aptos"/>
               </a:rPr>
-              <a:t>ingestion modes: file, JSON, IoT stream, feedback</a:t>
+              <a:t>data paths: file, JSON, IoT stream, simulator, feedback</a:t>
             </a:r>
           </a:p>
         </p:txBody>
@@ -4222,7 +4222,7 @@
                 <a:ea typeface="Aptos Mono"/>
                 <a:cs typeface="Aptos Mono"/>
               </a:rPr>
-              <a:t>Sources: README AI Capabilities, Current Capabilities, architecture data flow</a:t>
+              <a:t>Sources: README AI Capabilities, Monitoring, setup guide, architecture data flow</a:t>
             </a:r>
           </a:p>
         </p:txBody>
@@ -5034,7 +5034,7 @@
                 <a:ea typeface="Aptos Display"/>
                 <a:cs typeface="Aptos Display"/>
               </a:rPr>
-              <a:t>The prototype runs on a production-aligned local stack, from UI and APIs to RAG, streaming, and PEFT hooks.</a:t>
+              <a:t>The prototype runs on a production-aligned local stack, from UI and APIs to RAG, streaming, IoT monitoring, llama-server adapter serving, and PEFT hooks.</a:t>
             </a:r>
           </a:p>
         </p:txBody>
@@ -6254,7 +6254,7 @@
                 <a:ea typeface="Aptos"/>
                 <a:cs typeface="Aptos"/>
               </a:rPr>
-              <a:t>llama.cpp Qwen2.5 7B + LoRA adapter</a:t>
+              <a:t>llama-server Qwen2.5 7B base + LoRA adapter</a:t>
             </a:r>
           </a:p>
         </p:txBody>
@@ -6419,7 +6419,7 @@
                 <a:ea typeface="Aptos"/>
                 <a:cs typeface="Aptos"/>
               </a:rPr>
-              <a:t>Neo, Morpheus, Smith role-aware modes</a:t>
+              <a:t>Neo, Trinity, Morpheus, Smith role-aware modes</a:t>
             </a:r>
           </a:p>
         </p:txBody>
@@ -7574,7 +7574,7 @@
                 <a:ea typeface="Aptos"/>
                 <a:cs typeface="Aptos"/>
               </a:rPr>
-              <a:t>Bash scripts, Docker NATS/Qdrant, Kind runner</a:t>
+              <a:t>Bash scripts, Docker NATS/Qdrant, IoT simulator, Kind runner</a:t>
             </a:r>
           </a:p>
         </p:txBody>
@@ -7674,7 +7674,7 @@
                 <a:ea typeface="Aptos Mono"/>
                 <a:cs typeface="Aptos Mono"/>
               </a:rPr>
-              <a:t>Source: README.md Tech Stack</a:t>
+              <a:t>Source: README.md Tech Stack and setup guide</a:t>
             </a:r>
           </a:p>
         </p:txBody>
@@ -13139,14 +13139,14 @@
       </p:sp>
       <p:pic>
         <p:nvPicPr>
-          <p:cNvPr id="19" name=""/>
+          <p:cNvPr id="20" name=""/>
           <p:cNvPicPr>
             <a:picLocks xmlns:a="http://schemas.openxmlformats.org/drawingml/2006/main" noChangeAspect="1"/>
           </p:cNvPicPr>
           <p:nvPr/>
         </p:nvPicPr>
         <p:blipFill>
-          <a:blip xmlns:r="http://schemas.openxmlformats.org/officeDocument/2006/relationships" xmlns:a="http://schemas.openxmlformats.org/drawingml/2006/main" r:embed="Rb93ed529f60741d7"/>
+          <a:blip xmlns:r="http://schemas.openxmlformats.org/officeDocument/2006/relationships" xmlns:a="http://schemas.openxmlformats.org/drawingml/2006/main" r:embed="R6c10a8c6525c48a8"/>
           <a:srcRect xmlns:a="http://schemas.openxmlformats.org/drawingml/2006/main" l="0" t="0" r="0" b="0"/>
           <a:stretch xmlns:a="http://schemas.openxmlformats.org/drawingml/2006/main">
             <a:fillRect l="0" t="0" r="0" b="0"/>
@@ -13303,14 +13303,14 @@
       </p:sp>
       <p:pic>
         <p:nvPicPr>
-          <p:cNvPr id="23" name=""/>
+          <p:cNvPr id="24" name=""/>
           <p:cNvPicPr>
             <a:picLocks xmlns:a="http://schemas.openxmlformats.org/drawingml/2006/main" noChangeAspect="1"/>
           </p:cNvPicPr>
           <p:nvPr/>
         </p:nvPicPr>
         <p:blipFill>
-          <a:blip xmlns:r="http://schemas.openxmlformats.org/officeDocument/2006/relationships" xmlns:a="http://schemas.openxmlformats.org/drawingml/2006/main" r:embed="Rd852489dcff3440f"/>
+          <a:blip xmlns:r="http://schemas.openxmlformats.org/officeDocument/2006/relationships" xmlns:a="http://schemas.openxmlformats.org/drawingml/2006/main" r:embed="Rbfe1f326d26f4f0e"/>
           <a:stretch xmlns:a="http://schemas.openxmlformats.org/drawingml/2006/main"/>
         </p:blipFill>
         <p:spPr>
@@ -14065,7 +14065,7 @@
                 <a:ea typeface="Aptos Display"/>
                 <a:cs typeface="Aptos Display"/>
               </a:rPr>
-              <a:t>The three AI personas split the maintenance workload instead of acting like one generic chatbot.</a:t>
+              <a:t>The AI personas split the maintenance workload instead of acting like one generic chatbot.</a:t>
             </a:r>
           </a:p>
         </p:txBody>
@@ -14179,10 +14179,10 @@
           <p:nvPr/>
         </p:nvPicPr>
         <p:blipFill>
-          <a:blip xmlns:r="http://schemas.openxmlformats.org/officeDocument/2006/relationships" xmlns:a="http://schemas.openxmlformats.org/drawingml/2006/main" r:embed="R31119b298e214fda">
+          <a:blip xmlns:r="http://schemas.openxmlformats.org/officeDocument/2006/relationships" xmlns:a="http://schemas.openxmlformats.org/drawingml/2006/main" r:embed="R41ccb99a1e91431a">
             <a:extLst>
               <a:ext uri="{96DAC541-7B7A-43D3-8B79-37D633B846F1}">
-                <asvg:svgBlip xmlns:asvg="http://schemas.microsoft.com/office/drawing/2016/SVG/main" r:embed="Ra0f1e14848e14be8"/>
+                <asvg:svgBlip xmlns:asvg="http://schemas.microsoft.com/office/drawing/2016/SVG/main" r:embed="R3beb8f4992774202"/>
               </a:ext>
             </a:extLst>
           </a:blip>
@@ -14258,7 +14258,7 @@
                 <a:ea typeface="Aptos"/>
                 <a:cs typeface="Aptos"/>
               </a:rPr>
-              <a:t>Neo</a:t>
+              <a:t>Neo + Trinity</a:t>
             </a:r>
           </a:p>
         </p:txBody>
@@ -14323,7 +14323,7 @@
                 <a:ea typeface="Aptos"/>
                 <a:cs typeface="Aptos"/>
               </a:rPr>
-              <a:t>Operational copilot</a:t>
+              <a:t>Command center + work execution</a:t>
             </a:r>
           </a:p>
         </p:txBody>
@@ -14388,7 +14388,7 @@
                 <a:ea typeface="Aptos"/>
                 <a:cs typeface="Aptos"/>
               </a:rPr>
-              <a:t>Dashboard answers, role-aware welcomes, asset and work-order lookup, permission-checked commands, technician and supervisor modes.</a:t>
+              <a:t>Neo handles dashboard answers, asset lookup, and app-owned tables. Trinity guides technician execution, supervisor follow-up review, problem codes, completion summaries, and approved work-order actions.</a:t>
             </a:r>
           </a:p>
         </p:txBody>
@@ -14502,10 +14502,10 @@
           <p:nvPr/>
         </p:nvPicPr>
         <p:blipFill>
-          <a:blip xmlns:r="http://schemas.openxmlformats.org/officeDocument/2006/relationships" xmlns:a="http://schemas.openxmlformats.org/drawingml/2006/main" r:embed="R943966c51e6f42db">
+          <a:blip xmlns:r="http://schemas.openxmlformats.org/officeDocument/2006/relationships" xmlns:a="http://schemas.openxmlformats.org/drawingml/2006/main" r:embed="R7558cdd9e64a4448">
             <a:extLst>
               <a:ext uri="{96DAC541-7B7A-43D3-8B79-37D633B846F1}">
-                <asvg:svgBlip xmlns:asvg="http://schemas.microsoft.com/office/drawing/2016/SVG/main" r:embed="R0d9894829107406f"/>
+                <asvg:svgBlip xmlns:asvg="http://schemas.microsoft.com/office/drawing/2016/SVG/main" r:embed="R868cf63364df4775"/>
               </a:ext>
             </a:extLst>
           </a:blip>
@@ -14825,10 +14825,10 @@
           <p:nvPr/>
         </p:nvPicPr>
         <p:blipFill>
-          <a:blip xmlns:r="http://schemas.openxmlformats.org/officeDocument/2006/relationships" xmlns:a="http://schemas.openxmlformats.org/drawingml/2006/main" r:embed="R1f8f16f7c7d04d90">
+          <a:blip xmlns:r="http://schemas.openxmlformats.org/officeDocument/2006/relationships" xmlns:a="http://schemas.openxmlformats.org/drawingml/2006/main" r:embed="R218adcf5bf1541c7">
             <a:extLst>
               <a:ext uri="{96DAC541-7B7A-43D3-8B79-37D633B846F1}">
-                <asvg:svgBlip xmlns:asvg="http://schemas.microsoft.com/office/drawing/2016/SVG/main" r:embed="Refd8c37a9d604b24"/>
+                <asvg:svgBlip xmlns:asvg="http://schemas.microsoft.com/office/drawing/2016/SVG/main" r:embed="R2030e20453c24e70"/>
               </a:ext>
             </a:extLst>
           </a:blip>
@@ -20705,7 +20705,7 @@
                 <a:ea typeface="Aptos Mono"/>
                 <a:cs typeface="Aptos Mono"/>
               </a:rPr>
-              <a:t>INGESTION FABRIC</a:t>
+              <a:t>INGESTION + MONITORING FABRIC</a:t>
             </a:r>
           </a:p>
         </p:txBody>
@@ -20770,7 +20770,7 @@
                 <a:ea typeface="Aptos Display"/>
                 <a:cs typeface="Aptos Display"/>
               </a:rPr>
-              <a:t>Ingestion covers static knowledge, operational records, live IoT events, and learning signals.</a:t>
+              <a:t>Ingestion covers static knowledge, operational records, simulator-fed IoT telemetry, monitoring alerts, and learning signals.</a:t>
             </a:r>
           </a:p>
         </p:txBody>
@@ -20835,7 +20835,7 @@
                 <a:ea typeface="Aptos"/>
                 <a:cs typeface="Aptos"/>
               </a:rPr>
-              <a:t>Every path lands in typed storage and retrieval indexes so future diagnosis, prediction, planning, and reporting can reuse the evidence.</a:t>
+              <a:t>Every path lands in typed storage and retrieval indexes so monitoring, diagnosis, prediction, planning, and reporting can reuse the evidence.</a:t>
             </a:r>
           </a:p>
         </p:txBody>
@@ -21405,7 +21405,7 @@
                 <a:ea typeface="Aptos Mono"/>
                 <a:cs typeface="Aptos Mono"/>
               </a:rPr>
-              <a:t>NATS IOT</a:t>
+              <a:t>NATS IOT + SIM</a:t>
             </a:r>
           </a:p>
         </p:txBody>
@@ -21470,7 +21470,7 @@
                 <a:ea typeface="Aptos"/>
                 <a:cs typeface="Aptos"/>
               </a:rPr>
-              <a:t>JetStream durable consumer, ACK, DLQ</a:t>
+              <a:t>JetStream consumer, simulator, ACK, DLQ</a:t>
             </a:r>
           </a:p>
         </p:txBody>

</xml_diff>

<commit_message>
Update architecture diagram for monitoring runtime
</commit_message>
<xml_diff>
--- a/docs/decks/maintenance-wizard-ai-capabilities-hackathon-objectives.pptx
+++ b/docs/decks/maintenance-wizard-ai-capabilities-hackathon-objectives.pptx
@@ -2,25 +2,25 @@
 <file path=ppt/presentation.xml><?xml version="1.0" encoding="utf-8"?>
 <p:presentation xmlns:p="http://schemas.openxmlformats.org/presentationml/2006/main">
   <p:sldMasterIdLst>
-    <p:sldMasterId xmlns:r="http://schemas.openxmlformats.org/officeDocument/2006/relationships" id="2147483648" r:id="R67c54dfa8aa4439e"/>
+    <p:sldMasterId xmlns:r="http://schemas.openxmlformats.org/officeDocument/2006/relationships" id="2147483648" r:id="R9243e0c7767544e4"/>
   </p:sldMasterIdLst>
   <p:notesMasterIdLst>
-    <p:notesMasterId xmlns:r="http://schemas.openxmlformats.org/officeDocument/2006/relationships" r:id="Rd4ec280f619843ad"/>
+    <p:notesMasterId xmlns:r="http://schemas.openxmlformats.org/officeDocument/2006/relationships" r:id="Rbf39a90bb8cf4950"/>
   </p:notesMasterIdLst>
   <p:sldIdLst>
-    <p:sldId xmlns:r="http://schemas.openxmlformats.org/officeDocument/2006/relationships" id="256" r:id="R1ea84dd5cfaa4175"/>
-    <p:sldId xmlns:r="http://schemas.openxmlformats.org/officeDocument/2006/relationships" id="257" r:id="Ra97f56e0373c470d"/>
-    <p:sldId xmlns:r="http://schemas.openxmlformats.org/officeDocument/2006/relationships" id="258" r:id="Rcd35675efc3649fa"/>
-    <p:sldId xmlns:r="http://schemas.openxmlformats.org/officeDocument/2006/relationships" id="259" r:id="R66038532a7904761"/>
-    <p:sldId xmlns:r="http://schemas.openxmlformats.org/officeDocument/2006/relationships" id="260" r:id="R4f7bb3e6766f4e2c"/>
-    <p:sldId xmlns:r="http://schemas.openxmlformats.org/officeDocument/2006/relationships" id="261" r:id="R887f1a9cf5314860"/>
-    <p:sldId xmlns:r="http://schemas.openxmlformats.org/officeDocument/2006/relationships" id="262" r:id="Rfe58eed9aa224417"/>
-    <p:sldId xmlns:r="http://schemas.openxmlformats.org/officeDocument/2006/relationships" id="263" r:id="R6746a545ccd6456f"/>
-    <p:sldId xmlns:r="http://schemas.openxmlformats.org/officeDocument/2006/relationships" id="264" r:id="R8705718566604237"/>
-    <p:sldId xmlns:r="http://schemas.openxmlformats.org/officeDocument/2006/relationships" id="265" r:id="R7ce29a323682470b"/>
-    <p:sldId xmlns:r="http://schemas.openxmlformats.org/officeDocument/2006/relationships" id="266" r:id="R7ca0bccb2e5d4fe6"/>
-    <p:sldId xmlns:r="http://schemas.openxmlformats.org/officeDocument/2006/relationships" id="267" r:id="Rb79d0ecdd68a48f8"/>
-    <p:sldId xmlns:r="http://schemas.openxmlformats.org/officeDocument/2006/relationships" id="268" r:id="Rb83c51b02d0647ca"/>
+    <p:sldId xmlns:r="http://schemas.openxmlformats.org/officeDocument/2006/relationships" id="256" r:id="Rfb32999b12f74132"/>
+    <p:sldId xmlns:r="http://schemas.openxmlformats.org/officeDocument/2006/relationships" id="257" r:id="R39fd416f3959450a"/>
+    <p:sldId xmlns:r="http://schemas.openxmlformats.org/officeDocument/2006/relationships" id="258" r:id="Rc527cbd9b0274a62"/>
+    <p:sldId xmlns:r="http://schemas.openxmlformats.org/officeDocument/2006/relationships" id="259" r:id="R935627e97bf8406d"/>
+    <p:sldId xmlns:r="http://schemas.openxmlformats.org/officeDocument/2006/relationships" id="260" r:id="Rc7931c5178df4f84"/>
+    <p:sldId xmlns:r="http://schemas.openxmlformats.org/officeDocument/2006/relationships" id="261" r:id="R6dd49e62962c46c1"/>
+    <p:sldId xmlns:r="http://schemas.openxmlformats.org/officeDocument/2006/relationships" id="262" r:id="Ra0100911598c45c3"/>
+    <p:sldId xmlns:r="http://schemas.openxmlformats.org/officeDocument/2006/relationships" id="263" r:id="R757d15c43c984aac"/>
+    <p:sldId xmlns:r="http://schemas.openxmlformats.org/officeDocument/2006/relationships" id="264" r:id="R7d793f613c824362"/>
+    <p:sldId xmlns:r="http://schemas.openxmlformats.org/officeDocument/2006/relationships" id="265" r:id="R52cb79e600df4d1d"/>
+    <p:sldId xmlns:r="http://schemas.openxmlformats.org/officeDocument/2006/relationships" id="266" r:id="R7817427814674100"/>
+    <p:sldId xmlns:r="http://schemas.openxmlformats.org/officeDocument/2006/relationships" id="267" r:id="R89d8b180c5fc428f"/>
+    <p:sldId xmlns:r="http://schemas.openxmlformats.org/officeDocument/2006/relationships" id="268" r:id="Rdba2ade1791e4dbf"/>
   </p:sldIdLst>
   <p:sldSz cx="12192000" cy="6858000"/>
   <p:notesSz cx="6858000" cy="9144000"/>
@@ -1359,7 +1359,7 @@
   </p:cSld>
   <p:clrMap bg1="lt1" tx1="dk1" bg2="lt2" tx2="dk2" accent1="accent1" accent2="accent2" accent3="accent3" accent4="accent4" accent5="accent5" accent6="accent6" hlink="hlink" folHlink="folHlink"/>
   <p:sldLayoutIdLst>
-    <p:sldLayoutId xmlns:r="http://schemas.openxmlformats.org/officeDocument/2006/relationships" id="2147483649" r:id="R42c146aad33f4442"/>
+    <p:sldLayoutId xmlns:r="http://schemas.openxmlformats.org/officeDocument/2006/relationships" id="2147483649" r:id="Racd869464edb4e41"/>
   </p:sldLayoutIdLst>
   <p:txStyles>
     <p:titleStyle>
@@ -13146,14 +13146,14 @@
           <p:nvPr/>
         </p:nvPicPr>
         <p:blipFill>
-          <a:blip xmlns:r="http://schemas.openxmlformats.org/officeDocument/2006/relationships" xmlns:a="http://schemas.openxmlformats.org/drawingml/2006/main" r:embed="R6c10a8c6525c48a8"/>
+          <a:blip xmlns:r="http://schemas.openxmlformats.org/officeDocument/2006/relationships" xmlns:a="http://schemas.openxmlformats.org/drawingml/2006/main" r:embed="R26db267f02e5429c"/>
           <a:srcRect xmlns:a="http://schemas.openxmlformats.org/drawingml/2006/main" l="0" t="0" r="0" b="0"/>
           <a:stretch xmlns:a="http://schemas.openxmlformats.org/drawingml/2006/main">
             <a:fillRect l="0" t="0" r="0" b="0"/>
           </a:stretch>
         </p:blipFill>
         <p:spPr>
-          <a:xfrm xmlns:a="http://schemas.openxmlformats.org/drawingml/2006/main">
+          <a:xfrm xmlns:a="http://schemas.openxmlformats.org/drawingml/2006/main" flipH="0" flipV="0">
             <a:off x="0" y="0"/>
             <a:ext cx="12192000" cy="6858000"/>
           </a:xfrm>
@@ -13310,11 +13310,11 @@
           <p:nvPr/>
         </p:nvPicPr>
         <p:blipFill>
-          <a:blip xmlns:r="http://schemas.openxmlformats.org/officeDocument/2006/relationships" xmlns:a="http://schemas.openxmlformats.org/drawingml/2006/main" r:embed="Rbfe1f326d26f4f0e"/>
+          <a:blip xmlns:r="http://schemas.openxmlformats.org/officeDocument/2006/relationships" xmlns:a="http://schemas.openxmlformats.org/drawingml/2006/main" r:embed="R2e75cda296bf4e13"/>
           <a:stretch xmlns:a="http://schemas.openxmlformats.org/drawingml/2006/main"/>
         </p:blipFill>
         <p:spPr>
-          <a:xfrm xmlns:a="http://schemas.openxmlformats.org/drawingml/2006/main">
+          <a:xfrm xmlns:a="http://schemas.openxmlformats.org/drawingml/2006/main" flipH="0" flipV="0">
             <a:off x="609600" y="0"/>
             <a:ext cx="10972800" cy="6858000"/>
           </a:xfrm>
@@ -14179,10 +14179,10 @@
           <p:nvPr/>
         </p:nvPicPr>
         <p:blipFill>
-          <a:blip xmlns:r="http://schemas.openxmlformats.org/officeDocument/2006/relationships" xmlns:a="http://schemas.openxmlformats.org/drawingml/2006/main" r:embed="R41ccb99a1e91431a">
+          <a:blip xmlns:r="http://schemas.openxmlformats.org/officeDocument/2006/relationships" xmlns:a="http://schemas.openxmlformats.org/drawingml/2006/main" r:embed="R1f584195e33e4e5f">
             <a:extLst>
               <a:ext uri="{96DAC541-7B7A-43D3-8B79-37D633B846F1}">
-                <asvg:svgBlip xmlns:asvg="http://schemas.microsoft.com/office/drawing/2016/SVG/main" r:embed="R3beb8f4992774202"/>
+                <asvg:svgBlip xmlns:asvg="http://schemas.microsoft.com/office/drawing/2016/SVG/main" r:embed="Rdbec1417a9fd4f49"/>
               </a:ext>
             </a:extLst>
           </a:blip>
@@ -14502,10 +14502,10 @@
           <p:nvPr/>
         </p:nvPicPr>
         <p:blipFill>
-          <a:blip xmlns:r="http://schemas.openxmlformats.org/officeDocument/2006/relationships" xmlns:a="http://schemas.openxmlformats.org/drawingml/2006/main" r:embed="R7558cdd9e64a4448">
+          <a:blip xmlns:r="http://schemas.openxmlformats.org/officeDocument/2006/relationships" xmlns:a="http://schemas.openxmlformats.org/drawingml/2006/main" r:embed="R4550c33bada9489e">
             <a:extLst>
               <a:ext uri="{96DAC541-7B7A-43D3-8B79-37D633B846F1}">
-                <asvg:svgBlip xmlns:asvg="http://schemas.microsoft.com/office/drawing/2016/SVG/main" r:embed="R868cf63364df4775"/>
+                <asvg:svgBlip xmlns:asvg="http://schemas.microsoft.com/office/drawing/2016/SVG/main" r:embed="R8645894a47524ea7"/>
               </a:ext>
             </a:extLst>
           </a:blip>
@@ -14825,10 +14825,10 @@
           <p:nvPr/>
         </p:nvPicPr>
         <p:blipFill>
-          <a:blip xmlns:r="http://schemas.openxmlformats.org/officeDocument/2006/relationships" xmlns:a="http://schemas.openxmlformats.org/drawingml/2006/main" r:embed="R218adcf5bf1541c7">
+          <a:blip xmlns:r="http://schemas.openxmlformats.org/officeDocument/2006/relationships" xmlns:a="http://schemas.openxmlformats.org/drawingml/2006/main" r:embed="R696fb94b9b054399">
             <a:extLst>
               <a:ext uri="{96DAC541-7B7A-43D3-8B79-37D633B846F1}">
-                <asvg:svgBlip xmlns:asvg="http://schemas.microsoft.com/office/drawing/2016/SVG/main" r:embed="R2030e20453c24e70"/>
+                <asvg:svgBlip xmlns:asvg="http://schemas.microsoft.com/office/drawing/2016/SVG/main" r:embed="Rc604ab391ef047ba"/>
               </a:ext>
             </a:extLst>
           </a:blip>

</xml_diff>